<commit_message>
adição de power point final para submissao com inicio do design final
</commit_message>
<xml_diff>
--- a/projeto_fp_tp10.pptx
+++ b/projeto_fp_tp10.pptx
@@ -113,6 +113,11 @@
       </a:defRPr>
     </a:lvl9pPr>
   </p:defaultTextStyle>
+  <p:extLst>
+    <p:ext uri="{EFAFB233-063F-42B5-8137-9DF3F51BA10A}">
+      <p15:sldGuideLst xmlns:p15="http://schemas.microsoft.com/office/powerpoint/2012/main"/>
+    </p:ext>
+  </p:extLst>
 </p:presentation>
 </file>
 
@@ -129,12 +134,12 @@
   <pc:docChgLst>
     <pc:chgData name="Gabriela Carneiro" userId="038eca41cd8564ab" providerId="LiveId" clId="{D03F746D-BE5D-4789-93E6-42C6E52F57A2}"/>
     <pc:docChg chg="undo custSel addSld modSld sldOrd addMainMaster delMainMaster">
-      <pc:chgData name="Gabriela Carneiro" userId="038eca41cd8564ab" providerId="LiveId" clId="{D03F746D-BE5D-4789-93E6-42C6E52F57A2}" dt="2026-04-28T20:58:15.437" v="686"/>
+      <pc:chgData name="Gabriela Carneiro" userId="038eca41cd8564ab" providerId="LiveId" clId="{D03F746D-BE5D-4789-93E6-42C6E52F57A2}" dt="2026-04-29T20:21:35.612" v="713" actId="1076"/>
       <pc:docMkLst>
         <pc:docMk/>
       </pc:docMkLst>
       <pc:sldChg chg="addSp delSp modSp mod ord setBg modClrScheme addAnim delAnim delDesignElem chgLayout">
-        <pc:chgData name="Gabriela Carneiro" userId="038eca41cd8564ab" providerId="LiveId" clId="{D03F746D-BE5D-4789-93E6-42C6E52F57A2}" dt="2026-04-28T20:43:27.707" v="485" actId="478"/>
+        <pc:chgData name="Gabriela Carneiro" userId="038eca41cd8564ab" providerId="LiveId" clId="{D03F746D-BE5D-4789-93E6-42C6E52F57A2}" dt="2026-04-29T20:21:35.612" v="713" actId="1076"/>
         <pc:sldMkLst>
           <pc:docMk/>
           <pc:sldMk cId="334472207" sldId="256"/>
@@ -172,7 +177,7 @@
           </ac:spMkLst>
         </pc:spChg>
         <pc:spChg chg="add mod">
-          <ac:chgData name="Gabriela Carneiro" userId="038eca41cd8564ab" providerId="LiveId" clId="{D03F746D-BE5D-4789-93E6-42C6E52F57A2}" dt="2026-04-28T19:24:32.657" v="226" actId="20577"/>
+          <ac:chgData name="Gabriela Carneiro" userId="038eca41cd8564ab" providerId="LiveId" clId="{D03F746D-BE5D-4789-93E6-42C6E52F57A2}" dt="2026-04-29T20:21:35.612" v="713" actId="1076"/>
           <ac:spMkLst>
             <pc:docMk/>
             <pc:sldMk cId="334472207" sldId="256"/>
@@ -284,14 +289,14 @@
           </ac:cxnSpMkLst>
         </pc:cxnChg>
       </pc:sldChg>
-      <pc:sldChg chg="addSp delSp modSp new mod">
-        <pc:chgData name="Gabriela Carneiro" userId="038eca41cd8564ab" providerId="LiveId" clId="{D03F746D-BE5D-4789-93E6-42C6E52F57A2}" dt="2026-04-28T20:43:37.410" v="487" actId="478"/>
+      <pc:sldChg chg="addSp delSp modSp new mod ord">
+        <pc:chgData name="Gabriela Carneiro" userId="038eca41cd8564ab" providerId="LiveId" clId="{D03F746D-BE5D-4789-93E6-42C6E52F57A2}" dt="2026-04-29T16:51:38.945" v="712" actId="20577"/>
         <pc:sldMkLst>
           <pc:docMk/>
           <pc:sldMk cId="4265899404" sldId="257"/>
         </pc:sldMkLst>
         <pc:spChg chg="mod">
-          <ac:chgData name="Gabriela Carneiro" userId="038eca41cd8564ab" providerId="LiveId" clId="{D03F746D-BE5D-4789-93E6-42C6E52F57A2}" dt="2026-04-28T20:17:43.937" v="281" actId="20577"/>
+          <ac:chgData name="Gabriela Carneiro" userId="038eca41cd8564ab" providerId="LiveId" clId="{D03F746D-BE5D-4789-93E6-42C6E52F57A2}" dt="2026-04-29T16:51:38.945" v="712" actId="20577"/>
           <ac:spMkLst>
             <pc:docMk/>
             <pc:sldMk cId="4265899404" sldId="257"/>
@@ -631,101 +636,6 @@
             <pc:docMk/>
             <pc:sldMasterMk cId="4021644389" sldId="2147483660"/>
             <pc:sldLayoutMk cId="1620018748" sldId="2147483676"/>
-          </pc:sldLayoutMkLst>
-        </pc:sldLayoutChg>
-      </pc:sldMasterChg>
-      <pc:sldMasterChg chg="add del replId addSldLayout delSldLayout">
-        <pc:chgData name="Gabriela Carneiro" userId="038eca41cd8564ab" providerId="LiveId" clId="{D03F746D-BE5D-4789-93E6-42C6E52F57A2}" dt="2026-04-28T18:54:33.043" v="7" actId="26606"/>
-        <pc:sldMasterMkLst>
-          <pc:docMk/>
-          <pc:sldMasterMk cId="1706574332" sldId="2147483677"/>
-        </pc:sldMasterMkLst>
-        <pc:sldLayoutChg chg="add del replId">
-          <pc:chgData name="Gabriela Carneiro" userId="038eca41cd8564ab" providerId="LiveId" clId="{D03F746D-BE5D-4789-93E6-42C6E52F57A2}" dt="2026-04-28T18:54:33.043" v="7" actId="26606"/>
-          <pc:sldLayoutMkLst>
-            <pc:docMk/>
-            <pc:sldMasterMk cId="1706574332" sldId="2147483677"/>
-            <pc:sldLayoutMk cId="4169075916" sldId="2147483678"/>
-          </pc:sldLayoutMkLst>
-        </pc:sldLayoutChg>
-        <pc:sldLayoutChg chg="add del replId">
-          <pc:chgData name="Gabriela Carneiro" userId="038eca41cd8564ab" providerId="LiveId" clId="{D03F746D-BE5D-4789-93E6-42C6E52F57A2}" dt="2026-04-28T18:54:33.043" v="7" actId="26606"/>
-          <pc:sldLayoutMkLst>
-            <pc:docMk/>
-            <pc:sldMasterMk cId="1706574332" sldId="2147483677"/>
-            <pc:sldLayoutMk cId="3971105433" sldId="2147483679"/>
-          </pc:sldLayoutMkLst>
-        </pc:sldLayoutChg>
-        <pc:sldLayoutChg chg="add del replId">
-          <pc:chgData name="Gabriela Carneiro" userId="038eca41cd8564ab" providerId="LiveId" clId="{D03F746D-BE5D-4789-93E6-42C6E52F57A2}" dt="2026-04-28T18:54:33.043" v="7" actId="26606"/>
-          <pc:sldLayoutMkLst>
-            <pc:docMk/>
-            <pc:sldMasterMk cId="1706574332" sldId="2147483677"/>
-            <pc:sldLayoutMk cId="2809624590" sldId="2147483680"/>
-          </pc:sldLayoutMkLst>
-        </pc:sldLayoutChg>
-        <pc:sldLayoutChg chg="add del replId">
-          <pc:chgData name="Gabriela Carneiro" userId="038eca41cd8564ab" providerId="LiveId" clId="{D03F746D-BE5D-4789-93E6-42C6E52F57A2}" dt="2026-04-28T18:54:33.043" v="7" actId="26606"/>
-          <pc:sldLayoutMkLst>
-            <pc:docMk/>
-            <pc:sldMasterMk cId="1706574332" sldId="2147483677"/>
-            <pc:sldLayoutMk cId="46483895" sldId="2147483681"/>
-          </pc:sldLayoutMkLst>
-        </pc:sldLayoutChg>
-        <pc:sldLayoutChg chg="add del replId">
-          <pc:chgData name="Gabriela Carneiro" userId="038eca41cd8564ab" providerId="LiveId" clId="{D03F746D-BE5D-4789-93E6-42C6E52F57A2}" dt="2026-04-28T18:54:33.043" v="7" actId="26606"/>
-          <pc:sldLayoutMkLst>
-            <pc:docMk/>
-            <pc:sldMasterMk cId="1706574332" sldId="2147483677"/>
-            <pc:sldLayoutMk cId="1032196476" sldId="2147483682"/>
-          </pc:sldLayoutMkLst>
-        </pc:sldLayoutChg>
-        <pc:sldLayoutChg chg="add del replId">
-          <pc:chgData name="Gabriela Carneiro" userId="038eca41cd8564ab" providerId="LiveId" clId="{D03F746D-BE5D-4789-93E6-42C6E52F57A2}" dt="2026-04-28T18:54:33.043" v="7" actId="26606"/>
-          <pc:sldLayoutMkLst>
-            <pc:docMk/>
-            <pc:sldMasterMk cId="1706574332" sldId="2147483677"/>
-            <pc:sldLayoutMk cId="1147285346" sldId="2147483683"/>
-          </pc:sldLayoutMkLst>
-        </pc:sldLayoutChg>
-        <pc:sldLayoutChg chg="add del replId">
-          <pc:chgData name="Gabriela Carneiro" userId="038eca41cd8564ab" providerId="LiveId" clId="{D03F746D-BE5D-4789-93E6-42C6E52F57A2}" dt="2026-04-28T18:54:33.043" v="7" actId="26606"/>
-          <pc:sldLayoutMkLst>
-            <pc:docMk/>
-            <pc:sldMasterMk cId="1706574332" sldId="2147483677"/>
-            <pc:sldLayoutMk cId="356839949" sldId="2147483684"/>
-          </pc:sldLayoutMkLst>
-        </pc:sldLayoutChg>
-        <pc:sldLayoutChg chg="add del replId">
-          <pc:chgData name="Gabriela Carneiro" userId="038eca41cd8564ab" providerId="LiveId" clId="{D03F746D-BE5D-4789-93E6-42C6E52F57A2}" dt="2026-04-28T18:54:33.043" v="7" actId="26606"/>
-          <pc:sldLayoutMkLst>
-            <pc:docMk/>
-            <pc:sldMasterMk cId="1706574332" sldId="2147483677"/>
-            <pc:sldLayoutMk cId="2141797413" sldId="2147483685"/>
-          </pc:sldLayoutMkLst>
-        </pc:sldLayoutChg>
-        <pc:sldLayoutChg chg="add del replId">
-          <pc:chgData name="Gabriela Carneiro" userId="038eca41cd8564ab" providerId="LiveId" clId="{D03F746D-BE5D-4789-93E6-42C6E52F57A2}" dt="2026-04-28T18:54:33.043" v="7" actId="26606"/>
-          <pc:sldLayoutMkLst>
-            <pc:docMk/>
-            <pc:sldMasterMk cId="1706574332" sldId="2147483677"/>
-            <pc:sldLayoutMk cId="3203792654" sldId="2147483686"/>
-          </pc:sldLayoutMkLst>
-        </pc:sldLayoutChg>
-        <pc:sldLayoutChg chg="add del replId">
-          <pc:chgData name="Gabriela Carneiro" userId="038eca41cd8564ab" providerId="LiveId" clId="{D03F746D-BE5D-4789-93E6-42C6E52F57A2}" dt="2026-04-28T18:54:33.043" v="7" actId="26606"/>
-          <pc:sldLayoutMkLst>
-            <pc:docMk/>
-            <pc:sldMasterMk cId="1706574332" sldId="2147483677"/>
-            <pc:sldLayoutMk cId="4255237317" sldId="2147483687"/>
-          </pc:sldLayoutMkLst>
-        </pc:sldLayoutChg>
-        <pc:sldLayoutChg chg="add del replId">
-          <pc:chgData name="Gabriela Carneiro" userId="038eca41cd8564ab" providerId="LiveId" clId="{D03F746D-BE5D-4789-93E6-42C6E52F57A2}" dt="2026-04-28T18:54:33.043" v="7" actId="26606"/>
-          <pc:sldLayoutMkLst>
-            <pc:docMk/>
-            <pc:sldMasterMk cId="1706574332" sldId="2147483677"/>
-            <pc:sldLayoutMk cId="1776009374" sldId="2147483688"/>
           </pc:sldLayoutMkLst>
         </pc:sldLayoutChg>
       </pc:sldMasterChg>
@@ -1071,7 +981,7 @@
           <a:p>
             <a:fld id="{7DA38F49-B3E2-4BF0-BEC7-C30D34ABBB8D}" type="datetime1">
               <a:rPr lang="en-US" smtClean="0"/>
-              <a:t>4/28/2026</a:t>
+              <a:t>4/29/2026</a:t>
             </a:fld>
             <a:endParaRPr lang="en-US"/>
           </a:p>
@@ -1270,7 +1180,7 @@
           <a:p>
             <a:fld id="{7DA38F49-B3E2-4BF0-BEC7-C30D34ABBB8D}" type="datetime1">
               <a:rPr lang="en-US" smtClean="0"/>
-              <a:t>4/28/2026</a:t>
+              <a:t>4/29/2026</a:t>
             </a:fld>
             <a:endParaRPr lang="en-US"/>
           </a:p>
@@ -1479,7 +1389,7 @@
           <a:p>
             <a:fld id="{7DA38F49-B3E2-4BF0-BEC7-C30D34ABBB8D}" type="datetime1">
               <a:rPr lang="en-US" smtClean="0"/>
-              <a:t>4/28/2026</a:t>
+              <a:t>4/29/2026</a:t>
             </a:fld>
             <a:endParaRPr lang="en-US"/>
           </a:p>
@@ -1678,7 +1588,7 @@
           <a:p>
             <a:fld id="{7DA38F49-B3E2-4BF0-BEC7-C30D34ABBB8D}" type="datetime1">
               <a:rPr lang="en-US" smtClean="0"/>
-              <a:t>4/28/2026</a:t>
+              <a:t>4/29/2026</a:t>
             </a:fld>
             <a:endParaRPr lang="en-US"/>
           </a:p>
@@ -1954,7 +1864,7 @@
           <a:p>
             <a:fld id="{7DA38F49-B3E2-4BF0-BEC7-C30D34ABBB8D}" type="datetime1">
               <a:rPr lang="en-US" smtClean="0"/>
-              <a:t>4/28/2026</a:t>
+              <a:t>4/29/2026</a:t>
             </a:fld>
             <a:endParaRPr lang="en-US"/>
           </a:p>
@@ -2220,7 +2130,7 @@
           <a:p>
             <a:fld id="{7DA38F49-B3E2-4BF0-BEC7-C30D34ABBB8D}" type="datetime1">
               <a:rPr lang="en-US" smtClean="0"/>
-              <a:t>4/28/2026</a:t>
+              <a:t>4/29/2026</a:t>
             </a:fld>
             <a:endParaRPr lang="en-US"/>
           </a:p>
@@ -2633,7 +2543,7 @@
           <a:p>
             <a:fld id="{7DA38F49-B3E2-4BF0-BEC7-C30D34ABBB8D}" type="datetime1">
               <a:rPr lang="en-US" smtClean="0"/>
-              <a:t>4/28/2026</a:t>
+              <a:t>4/29/2026</a:t>
             </a:fld>
             <a:endParaRPr lang="en-US"/>
           </a:p>
@@ -2775,7 +2685,7 @@
           <a:p>
             <a:fld id="{7DA38F49-B3E2-4BF0-BEC7-C30D34ABBB8D}" type="datetime1">
               <a:rPr lang="en-US" smtClean="0"/>
-              <a:t>4/28/2026</a:t>
+              <a:t>4/29/2026</a:t>
             </a:fld>
             <a:endParaRPr lang="en-US"/>
           </a:p>
@@ -2889,7 +2799,7 @@
           <a:p>
             <a:fld id="{7DA38F49-B3E2-4BF0-BEC7-C30D34ABBB8D}" type="datetime1">
               <a:rPr lang="en-US" smtClean="0"/>
-              <a:t>4/28/2026</a:t>
+              <a:t>4/29/2026</a:t>
             </a:fld>
             <a:endParaRPr lang="en-US"/>
           </a:p>
@@ -3201,7 +3111,7 @@
           <a:p>
             <a:fld id="{7DA38F49-B3E2-4BF0-BEC7-C30D34ABBB8D}" type="datetime1">
               <a:rPr lang="en-US" smtClean="0"/>
-              <a:t>4/28/2026</a:t>
+              <a:t>4/29/2026</a:t>
             </a:fld>
             <a:endParaRPr lang="en-US"/>
           </a:p>
@@ -3490,7 +3400,7 @@
           <a:p>
             <a:fld id="{7DA38F49-B3E2-4BF0-BEC7-C30D34ABBB8D}" type="datetime1">
               <a:rPr lang="en-US" smtClean="0"/>
-              <a:t>4/28/2026</a:t>
+              <a:t>4/29/2026</a:t>
             </a:fld>
             <a:endParaRPr lang="en-US"/>
           </a:p>
@@ -3732,7 +3642,7 @@
           <a:p>
             <a:fld id="{7DA38F49-B3E2-4BF0-BEC7-C30D34ABBB8D}" type="datetime1">
               <a:rPr lang="en-US" smtClean="0"/>
-              <a:t>4/28/2026</a:t>
+              <a:t>4/29/2026</a:t>
             </a:fld>
             <a:endParaRPr lang="en-US"/>
           </a:p>
@@ -4305,7 +4215,7 @@
         </p:nvSpPr>
         <p:spPr>
           <a:xfrm>
-            <a:off x="661915" y="5098408"/>
+            <a:off x="661915" y="5070699"/>
             <a:ext cx="6097136" cy="1477328"/>
           </a:xfrm>
           <a:prstGeom prst="rect">
@@ -4660,7 +4570,7 @@
           <a:p>
             <a:r>
               <a:rPr lang="pt-PT" dirty="0"/>
-              <a:t>Racional</a:t>
+              <a:t>Racional </a:t>
             </a:r>
           </a:p>
         </p:txBody>

</xml_diff>